<commit_message>
Add more information to Presentation
</commit_message>
<xml_diff>
--- a/Presentation/JavaIOS.pptx
+++ b/Presentation/JavaIOS.pptx
@@ -5,14 +5,15 @@
     <p:sldMasterId id="2147483648" r:id="rId1"/>
   </p:sldMasterIdLst>
   <p:notesMasterIdLst>
-    <p:notesMasterId r:id="rId7"/>
+    <p:notesMasterId r:id="rId8"/>
   </p:notesMasterIdLst>
   <p:sldIdLst>
     <p:sldId id="256" r:id="rId2"/>
     <p:sldId id="265" r:id="rId3"/>
     <p:sldId id="271" r:id="rId4"/>
     <p:sldId id="269" r:id="rId5"/>
-    <p:sldId id="270" r:id="rId6"/>
+    <p:sldId id="272" r:id="rId6"/>
+    <p:sldId id="270" r:id="rId7"/>
   </p:sldIdLst>
   <p:sldSz cx="12192000" cy="6858000"/>
   <p:notesSz cx="6858000" cy="9144000"/>
@@ -201,7 +202,7 @@
           <a:p>
             <a:fld id="{9F2BA611-CD30-41A1-B46E-2F9966214A8A}" type="datetimeFigureOut">
               <a:rPr lang="fr-CH" smtClean="0"/>
-              <a:t>13.10.2025</a:t>
+              <a:t>15.10.2025</a:t>
             </a:fld>
             <a:endParaRPr lang="fr-CH"/>
           </a:p>
@@ -360,7 +361,7 @@
           <a:p>
             <a:fld id="{CDBDB67E-2F49-4B82-BD34-80F660E668E3}" type="slidenum">
               <a:rPr lang="fr-CH" smtClean="0"/>
-              <a:t>‹N°›</a:t>
+              <a:t>‹#›</a:t>
             </a:fld>
             <a:endParaRPr lang="fr-CH"/>
           </a:p>
@@ -618,7 +619,7 @@
           <a:p>
             <a:fld id="{26AF8319-CBBE-4308-B4C7-811589C54584}" type="datetimeFigureOut">
               <a:rPr lang="fr-CH" smtClean="0"/>
-              <a:t>13.10.2025</a:t>
+              <a:t>15.10.2025</a:t>
             </a:fld>
             <a:endParaRPr lang="fr-CH"/>
           </a:p>
@@ -672,7 +673,7 @@
           <a:p>
             <a:fld id="{5A2DBB11-DE35-4FE9-8750-3AA697731A11}" type="slidenum">
               <a:rPr lang="fr-CH" smtClean="0"/>
-              <a:t>‹N°›</a:t>
+              <a:t>‹#›</a:t>
             </a:fld>
             <a:endParaRPr lang="fr-CH"/>
           </a:p>
@@ -818,7 +819,7 @@
           <a:p>
             <a:fld id="{26AF8319-CBBE-4308-B4C7-811589C54584}" type="datetimeFigureOut">
               <a:rPr lang="fr-CH" smtClean="0"/>
-              <a:t>13.10.2025</a:t>
+              <a:t>15.10.2025</a:t>
             </a:fld>
             <a:endParaRPr lang="fr-CH"/>
           </a:p>
@@ -872,7 +873,7 @@
           <a:p>
             <a:fld id="{5A2DBB11-DE35-4FE9-8750-3AA697731A11}" type="slidenum">
               <a:rPr lang="fr-CH" smtClean="0"/>
-              <a:t>‹N°›</a:t>
+              <a:t>‹#›</a:t>
             </a:fld>
             <a:endParaRPr lang="fr-CH"/>
           </a:p>
@@ -1028,7 +1029,7 @@
           <a:p>
             <a:fld id="{26AF8319-CBBE-4308-B4C7-811589C54584}" type="datetimeFigureOut">
               <a:rPr lang="fr-CH" smtClean="0"/>
-              <a:t>13.10.2025</a:t>
+              <a:t>15.10.2025</a:t>
             </a:fld>
             <a:endParaRPr lang="fr-CH"/>
           </a:p>
@@ -1082,7 +1083,7 @@
           <a:p>
             <a:fld id="{5A2DBB11-DE35-4FE9-8750-3AA697731A11}" type="slidenum">
               <a:rPr lang="fr-CH" smtClean="0"/>
-              <a:t>‹N°›</a:t>
+              <a:t>‹#›</a:t>
             </a:fld>
             <a:endParaRPr lang="fr-CH"/>
           </a:p>
@@ -1228,7 +1229,7 @@
           <a:p>
             <a:fld id="{26AF8319-CBBE-4308-B4C7-811589C54584}" type="datetimeFigureOut">
               <a:rPr lang="fr-CH" smtClean="0"/>
-              <a:t>13.10.2025</a:t>
+              <a:t>15.10.2025</a:t>
             </a:fld>
             <a:endParaRPr lang="fr-CH"/>
           </a:p>
@@ -1282,7 +1283,7 @@
           <a:p>
             <a:fld id="{5A2DBB11-DE35-4FE9-8750-3AA697731A11}" type="slidenum">
               <a:rPr lang="fr-CH" smtClean="0"/>
-              <a:t>‹N°›</a:t>
+              <a:t>‹#›</a:t>
             </a:fld>
             <a:endParaRPr lang="fr-CH"/>
           </a:p>
@@ -1504,7 +1505,7 @@
           <a:p>
             <a:fld id="{26AF8319-CBBE-4308-B4C7-811589C54584}" type="datetimeFigureOut">
               <a:rPr lang="fr-CH" smtClean="0"/>
-              <a:t>13.10.2025</a:t>
+              <a:t>15.10.2025</a:t>
             </a:fld>
             <a:endParaRPr lang="fr-CH"/>
           </a:p>
@@ -1558,7 +1559,7 @@
           <a:p>
             <a:fld id="{5A2DBB11-DE35-4FE9-8750-3AA697731A11}" type="slidenum">
               <a:rPr lang="fr-CH" smtClean="0"/>
-              <a:t>‹N°›</a:t>
+              <a:t>‹#›</a:t>
             </a:fld>
             <a:endParaRPr lang="fr-CH"/>
           </a:p>
@@ -1772,7 +1773,7 @@
           <a:p>
             <a:fld id="{26AF8319-CBBE-4308-B4C7-811589C54584}" type="datetimeFigureOut">
               <a:rPr lang="fr-CH" smtClean="0"/>
-              <a:t>13.10.2025</a:t>
+              <a:t>15.10.2025</a:t>
             </a:fld>
             <a:endParaRPr lang="fr-CH"/>
           </a:p>
@@ -1826,7 +1827,7 @@
           <a:p>
             <a:fld id="{5A2DBB11-DE35-4FE9-8750-3AA697731A11}" type="slidenum">
               <a:rPr lang="fr-CH" smtClean="0"/>
-              <a:t>‹N°›</a:t>
+              <a:t>‹#›</a:t>
             </a:fld>
             <a:endParaRPr lang="fr-CH"/>
           </a:p>
@@ -2187,7 +2188,7 @@
           <a:p>
             <a:fld id="{26AF8319-CBBE-4308-B4C7-811589C54584}" type="datetimeFigureOut">
               <a:rPr lang="fr-CH" smtClean="0"/>
-              <a:t>13.10.2025</a:t>
+              <a:t>15.10.2025</a:t>
             </a:fld>
             <a:endParaRPr lang="fr-CH"/>
           </a:p>
@@ -2241,7 +2242,7 @@
           <a:p>
             <a:fld id="{5A2DBB11-DE35-4FE9-8750-3AA697731A11}" type="slidenum">
               <a:rPr lang="fr-CH" smtClean="0"/>
-              <a:t>‹N°›</a:t>
+              <a:t>‹#›</a:t>
             </a:fld>
             <a:endParaRPr lang="fr-CH"/>
           </a:p>
@@ -2329,7 +2330,7 @@
           <a:p>
             <a:fld id="{26AF8319-CBBE-4308-B4C7-811589C54584}" type="datetimeFigureOut">
               <a:rPr lang="fr-CH" smtClean="0"/>
-              <a:t>13.10.2025</a:t>
+              <a:t>15.10.2025</a:t>
             </a:fld>
             <a:endParaRPr lang="fr-CH"/>
           </a:p>
@@ -2383,7 +2384,7 @@
           <a:p>
             <a:fld id="{5A2DBB11-DE35-4FE9-8750-3AA697731A11}" type="slidenum">
               <a:rPr lang="fr-CH" smtClean="0"/>
-              <a:t>‹N°›</a:t>
+              <a:t>‹#›</a:t>
             </a:fld>
             <a:endParaRPr lang="fr-CH"/>
           </a:p>
@@ -2442,7 +2443,7 @@
           <a:p>
             <a:fld id="{26AF8319-CBBE-4308-B4C7-811589C54584}" type="datetimeFigureOut">
               <a:rPr lang="fr-CH" smtClean="0"/>
-              <a:t>13.10.2025</a:t>
+              <a:t>15.10.2025</a:t>
             </a:fld>
             <a:endParaRPr lang="fr-CH"/>
           </a:p>
@@ -2496,7 +2497,7 @@
           <a:p>
             <a:fld id="{5A2DBB11-DE35-4FE9-8750-3AA697731A11}" type="slidenum">
               <a:rPr lang="fr-CH" smtClean="0"/>
-              <a:t>‹N°›</a:t>
+              <a:t>‹#›</a:t>
             </a:fld>
             <a:endParaRPr lang="fr-CH"/>
           </a:p>
@@ -2755,7 +2756,7 @@
           <a:p>
             <a:fld id="{26AF8319-CBBE-4308-B4C7-811589C54584}" type="datetimeFigureOut">
               <a:rPr lang="fr-CH" smtClean="0"/>
-              <a:t>13.10.2025</a:t>
+              <a:t>15.10.2025</a:t>
             </a:fld>
             <a:endParaRPr lang="fr-CH"/>
           </a:p>
@@ -2809,7 +2810,7 @@
           <a:p>
             <a:fld id="{5A2DBB11-DE35-4FE9-8750-3AA697731A11}" type="slidenum">
               <a:rPr lang="fr-CH" smtClean="0"/>
-              <a:t>‹N°›</a:t>
+              <a:t>‹#›</a:t>
             </a:fld>
             <a:endParaRPr lang="fr-CH"/>
           </a:p>
@@ -3044,7 +3045,7 @@
           <a:p>
             <a:fld id="{26AF8319-CBBE-4308-B4C7-811589C54584}" type="datetimeFigureOut">
               <a:rPr lang="fr-CH" smtClean="0"/>
-              <a:t>13.10.2025</a:t>
+              <a:t>15.10.2025</a:t>
             </a:fld>
             <a:endParaRPr lang="fr-CH"/>
           </a:p>
@@ -3098,7 +3099,7 @@
           <a:p>
             <a:fld id="{5A2DBB11-DE35-4FE9-8750-3AA697731A11}" type="slidenum">
               <a:rPr lang="fr-CH" smtClean="0"/>
-              <a:t>‹N°›</a:t>
+              <a:t>‹#›</a:t>
             </a:fld>
             <a:endParaRPr lang="fr-CH"/>
           </a:p>
@@ -3287,7 +3288,7 @@
           <a:p>
             <a:fld id="{26AF8319-CBBE-4308-B4C7-811589C54584}" type="datetimeFigureOut">
               <a:rPr lang="fr-CH" smtClean="0"/>
-              <a:t>13.10.2025</a:t>
+              <a:t>15.10.2025</a:t>
             </a:fld>
             <a:endParaRPr lang="fr-CH"/>
           </a:p>
@@ -3377,7 +3378,7 @@
           <a:p>
             <a:fld id="{5A2DBB11-DE35-4FE9-8750-3AA697731A11}" type="slidenum">
               <a:rPr lang="fr-CH" smtClean="0"/>
-              <a:t>‹N°›</a:t>
+              <a:t>‹#›</a:t>
             </a:fld>
             <a:endParaRPr lang="fr-CH"/>
           </a:p>
@@ -3759,15 +3760,73 @@
         </p:nvSpPr>
         <p:spPr>
           <a:xfrm>
-            <a:off x="1539676" y="4308868"/>
+            <a:off x="263326" y="6271018"/>
             <a:ext cx="9144000" cy="1655762"/>
           </a:xfrm>
         </p:spPr>
         <p:txBody>
-          <a:bodyPr/>
+          <a:bodyPr>
+            <a:normAutofit/>
+          </a:bodyPr>
           <a:lstStyle/>
           <a:p>
-            <a:endParaRPr lang="fr-CH" dirty="0"/>
+            <a:r>
+              <a:rPr lang="fr-CH" sz="2000" dirty="0">
+                <a:solidFill>
+                  <a:srgbClr val="002060"/>
+                </a:solidFill>
+                <a:ea typeface="+mj-ea"/>
+                <a:cs typeface="+mj-cs"/>
+              </a:rPr>
+              <a:t>By </a:t>
+            </a:r>
+            <a:r>
+              <a:rPr lang="fr-CH" sz="2000" dirty="0" err="1">
+                <a:solidFill>
+                  <a:srgbClr val="002060"/>
+                </a:solidFill>
+                <a:ea typeface="+mj-ea"/>
+                <a:cs typeface="+mj-cs"/>
+              </a:rPr>
+              <a:t>Matthey</a:t>
+            </a:r>
+            <a:r>
+              <a:rPr lang="fr-CH" sz="2000" dirty="0">
+                <a:solidFill>
+                  <a:srgbClr val="002060"/>
+                </a:solidFill>
+                <a:ea typeface="+mj-ea"/>
+                <a:cs typeface="+mj-cs"/>
+              </a:rPr>
+              <a:t> Thibault, </a:t>
+            </a:r>
+            <a:r>
+              <a:rPr lang="fr-FR" sz="2000" dirty="0" err="1">
+                <a:solidFill>
+                  <a:srgbClr val="002060"/>
+                </a:solidFill>
+                <a:ea typeface="+mj-ea"/>
+                <a:cs typeface="+mj-cs"/>
+              </a:rPr>
+              <a:t>Eschmann</a:t>
+            </a:r>
+            <a:r>
+              <a:rPr lang="fr-FR" sz="2000" dirty="0">
+                <a:solidFill>
+                  <a:srgbClr val="002060"/>
+                </a:solidFill>
+                <a:ea typeface="+mj-ea"/>
+                <a:cs typeface="+mj-cs"/>
+              </a:rPr>
+              <a:t> Quentin and Henriques Garfo Sofia</a:t>
+            </a:r>
+            <a:endParaRPr lang="fr-CH" sz="2000" dirty="0">
+              <a:solidFill>
+                <a:srgbClr val="002060"/>
+              </a:solidFill>
+              <a:ea typeface="+mj-ea"/>
+              <a:cs typeface="+mj-cs"/>
+            </a:endParaRPr>
           </a:p>
         </p:txBody>
       </p:sp>
@@ -6698,6 +6757,266 @@
 </file>
 
 <file path=ppt/slides/slide5.xml><?xml version="1.0" encoding="utf-8"?>
+<p:sld xmlns:a="http://schemas.openxmlformats.org/drawingml/2006/main" xmlns:r="http://schemas.openxmlformats.org/officeDocument/2006/relationships" xmlns:p="http://schemas.openxmlformats.org/presentationml/2006/main">
+  <p:cSld>
+    <p:spTree>
+      <p:nvGrpSpPr>
+        <p:cNvPr id="1" name=""/>
+        <p:cNvGrpSpPr/>
+        <p:nvPr/>
+      </p:nvGrpSpPr>
+      <p:grpSpPr>
+        <a:xfrm>
+          <a:off x="0" y="0"/>
+          <a:ext cx="0" cy="0"/>
+          <a:chOff x="0" y="0"/>
+          <a:chExt cx="0" cy="0"/>
+        </a:xfrm>
+      </p:grpSpPr>
+      <p:sp>
+        <p:nvSpPr>
+          <p:cNvPr id="2" name="Title 1">
+            <a:extLst>
+              <a:ext uri="{FF2B5EF4-FFF2-40B4-BE49-F238E27FC236}">
+                <a16:creationId xmlns:a16="http://schemas.microsoft.com/office/drawing/2014/main" id="{228061D4-3C8E-6406-8BD5-DA5EB74A15A6}"/>
+              </a:ext>
+            </a:extLst>
+          </p:cNvPr>
+          <p:cNvSpPr>
+            <a:spLocks noGrp="1"/>
+          </p:cNvSpPr>
+          <p:nvPr>
+            <p:ph type="title"/>
+          </p:nvPr>
+        </p:nvSpPr>
+        <p:spPr>
+          <a:xfrm>
+            <a:off x="3785941" y="2857902"/>
+            <a:ext cx="10515600" cy="1325563"/>
+          </a:xfrm>
+        </p:spPr>
+        <p:txBody>
+          <a:bodyPr/>
+          <a:lstStyle/>
+          <a:p>
+            <a:r>
+              <a:rPr lang="en-US" dirty="0">
+                <a:solidFill>
+                  <a:srgbClr val="002060"/>
+                </a:solidFill>
+              </a:rPr>
+              <a:t>Demo</a:t>
+            </a:r>
+            <a:endParaRPr lang="en-CH" dirty="0">
+              <a:solidFill>
+                <a:srgbClr val="002060"/>
+              </a:solidFill>
+            </a:endParaRPr>
+          </a:p>
+        </p:txBody>
+      </p:sp>
+      <p:grpSp>
+        <p:nvGrpSpPr>
+          <p:cNvPr id="4" name="Groupe 26">
+            <a:extLst>
+              <a:ext uri="{FF2B5EF4-FFF2-40B4-BE49-F238E27FC236}">
+                <a16:creationId xmlns:a16="http://schemas.microsoft.com/office/drawing/2014/main" id="{AD753DF0-7715-7861-CDFC-3E2995F1E91A}"/>
+              </a:ext>
+            </a:extLst>
+          </p:cNvPr>
+          <p:cNvGrpSpPr/>
+          <p:nvPr/>
+        </p:nvGrpSpPr>
+        <p:grpSpPr>
+          <a:xfrm>
+            <a:off x="-3252272" y="-1419558"/>
+            <a:ext cx="8080172" cy="3218724"/>
+            <a:chOff x="-3270248" y="-1491149"/>
+            <a:chExt cx="8080172" cy="3218724"/>
+          </a:xfrm>
+        </p:grpSpPr>
+        <p:sp>
+          <p:nvSpPr>
+            <p:cNvPr id="5" name="Rectangle 4">
+              <a:extLst>
+                <a:ext uri="{FF2B5EF4-FFF2-40B4-BE49-F238E27FC236}">
+                  <a16:creationId xmlns:a16="http://schemas.microsoft.com/office/drawing/2014/main" id="{C03EC9F6-B01C-E68F-F988-A2DBFA03908C}"/>
+                </a:ext>
+              </a:extLst>
+            </p:cNvPr>
+            <p:cNvSpPr/>
+            <p:nvPr/>
+          </p:nvSpPr>
+          <p:spPr>
+            <a:xfrm rot="1822382">
+              <a:off x="-3270248" y="-1491149"/>
+              <a:ext cx="6540496" cy="2612571"/>
+            </a:xfrm>
+            <a:prstGeom prst="rect">
+              <a:avLst/>
+            </a:prstGeom>
+            <a:solidFill>
+              <a:schemeClr val="tx2">
+                <a:lumMod val="25000"/>
+                <a:lumOff val="75000"/>
+              </a:schemeClr>
+            </a:solidFill>
+            <a:ln>
+              <a:solidFill>
+                <a:schemeClr val="bg1"/>
+              </a:solidFill>
+            </a:ln>
+          </p:spPr>
+          <p:style>
+            <a:lnRef idx="2">
+              <a:schemeClr val="dk1">
+                <a:shade val="15000"/>
+              </a:schemeClr>
+            </a:lnRef>
+            <a:fillRef idx="1">
+              <a:schemeClr val="dk1"/>
+            </a:fillRef>
+            <a:effectRef idx="0">
+              <a:schemeClr val="dk1"/>
+            </a:effectRef>
+            <a:fontRef idx="minor">
+              <a:schemeClr val="lt1"/>
+            </a:fontRef>
+          </p:style>
+          <p:txBody>
+            <a:bodyPr rtlCol="0" anchor="ctr"/>
+            <a:lstStyle/>
+            <a:p>
+              <a:pPr algn="ctr"/>
+              <a:endParaRPr lang="fr-CH"/>
+            </a:p>
+          </p:txBody>
+        </p:sp>
+        <p:sp>
+          <p:nvSpPr>
+            <p:cNvPr id="6" name="Rectangle 5">
+              <a:extLst>
+                <a:ext uri="{FF2B5EF4-FFF2-40B4-BE49-F238E27FC236}">
+                  <a16:creationId xmlns:a16="http://schemas.microsoft.com/office/drawing/2014/main" id="{E2D771C3-8962-66CB-BABB-FE287DF277D4}"/>
+                </a:ext>
+              </a:extLst>
+            </p:cNvPr>
+            <p:cNvSpPr/>
+            <p:nvPr/>
+          </p:nvSpPr>
+          <p:spPr>
+            <a:xfrm rot="342513">
+              <a:off x="-2886247" y="-1079519"/>
+              <a:ext cx="6540496" cy="2612571"/>
+            </a:xfrm>
+            <a:prstGeom prst="rect">
+              <a:avLst/>
+            </a:prstGeom>
+            <a:solidFill>
+              <a:schemeClr val="tx2">
+                <a:lumMod val="75000"/>
+                <a:lumOff val="25000"/>
+              </a:schemeClr>
+            </a:solidFill>
+            <a:ln>
+              <a:noFill/>
+            </a:ln>
+          </p:spPr>
+          <p:style>
+            <a:lnRef idx="2">
+              <a:schemeClr val="dk1">
+                <a:shade val="15000"/>
+              </a:schemeClr>
+            </a:lnRef>
+            <a:fillRef idx="1">
+              <a:schemeClr val="dk1"/>
+            </a:fillRef>
+            <a:effectRef idx="0">
+              <a:schemeClr val="dk1"/>
+            </a:effectRef>
+            <a:fontRef idx="minor">
+              <a:schemeClr val="lt1"/>
+            </a:fontRef>
+          </p:style>
+          <p:txBody>
+            <a:bodyPr rtlCol="0" anchor="ctr"/>
+            <a:lstStyle/>
+            <a:p>
+              <a:pPr algn="ctr"/>
+              <a:endParaRPr lang="fr-CH"/>
+            </a:p>
+          </p:txBody>
+        </p:sp>
+        <p:sp>
+          <p:nvSpPr>
+            <p:cNvPr id="7" name="Rectangle 6">
+              <a:extLst>
+                <a:ext uri="{FF2B5EF4-FFF2-40B4-BE49-F238E27FC236}">
+                  <a16:creationId xmlns:a16="http://schemas.microsoft.com/office/drawing/2014/main" id="{47E9FF49-DEE1-DA15-DBEB-FE5003257E9E}"/>
+                </a:ext>
+              </a:extLst>
+            </p:cNvPr>
+            <p:cNvSpPr/>
+            <p:nvPr/>
+          </p:nvSpPr>
+          <p:spPr>
+            <a:xfrm rot="19358576">
+              <a:off x="-1730572" y="-884996"/>
+              <a:ext cx="6540496" cy="2612571"/>
+            </a:xfrm>
+            <a:prstGeom prst="rect">
+              <a:avLst/>
+            </a:prstGeom>
+            <a:solidFill>
+              <a:schemeClr val="tx2">
+                <a:lumMod val="90000"/>
+                <a:lumOff val="10000"/>
+              </a:schemeClr>
+            </a:solidFill>
+            <a:ln>
+              <a:noFill/>
+            </a:ln>
+          </p:spPr>
+          <p:style>
+            <a:lnRef idx="2">
+              <a:schemeClr val="dk1">
+                <a:shade val="15000"/>
+              </a:schemeClr>
+            </a:lnRef>
+            <a:fillRef idx="1">
+              <a:schemeClr val="dk1"/>
+            </a:fillRef>
+            <a:effectRef idx="0">
+              <a:schemeClr val="dk1"/>
+            </a:effectRef>
+            <a:fontRef idx="minor">
+              <a:schemeClr val="lt1"/>
+            </a:fontRef>
+          </p:style>
+          <p:txBody>
+            <a:bodyPr rtlCol="0" anchor="ctr"/>
+            <a:lstStyle/>
+            <a:p>
+              <a:pPr algn="ctr"/>
+              <a:endParaRPr lang="fr-CH" dirty="0"/>
+            </a:p>
+          </p:txBody>
+        </p:sp>
+      </p:grpSp>
+    </p:spTree>
+    <p:extLst>
+      <p:ext uri="{BB962C8B-B14F-4D97-AF65-F5344CB8AC3E}">
+        <p14:creationId xmlns:p14="http://schemas.microsoft.com/office/powerpoint/2010/main" val="2848286321"/>
+      </p:ext>
+    </p:extLst>
+  </p:cSld>
+  <p:clrMapOvr>
+    <a:masterClrMapping/>
+  </p:clrMapOvr>
+</p:sld>
+</file>
+
+<file path=ppt/slides/slide6.xml><?xml version="1.0" encoding="utf-8"?>
 <p:sld xmlns:a="http://schemas.openxmlformats.org/drawingml/2006/main" xmlns:r="http://schemas.openxmlformats.org/officeDocument/2006/relationships" xmlns:p="http://schemas.openxmlformats.org/presentationml/2006/main">
   <p:cSld>
     <p:spTree>

</xml_diff>